<commit_message>
Add wiring overview source and exports
</commit_message>
<xml_diff>
--- a/docs/wiring/System_Wiring_Overview_v1.pptx
+++ b/docs/wiring/System_Wiring_Overview_v1.pptx
@@ -216,7 +216,7 @@
           <a:p>
             <a:fld id="{F521DC9C-5ECE-44DC-A71D-63CDFD8313D4}" type="datetimeFigureOut">
               <a:rPr lang="en-US" smtClean="0"/>
-              <a:t>5/20/2026</a:t>
+              <a:t>5/30/2026</a:t>
             </a:fld>
             <a:endParaRPr lang="en-US"/>
           </a:p>
@@ -714,7 +714,7 @@
           <a:p>
             <a:fld id="{57E72EBA-6B7C-4CB3-AA5D-1DBC4F41AF0A}" type="datetimeFigureOut">
               <a:rPr lang="en-US" smtClean="0"/>
-              <a:t>5/20/2026</a:t>
+              <a:t>5/30/2026</a:t>
             </a:fld>
             <a:endParaRPr lang="en-US"/>
           </a:p>
@@ -912,7 +912,7 @@
           <a:p>
             <a:fld id="{57E72EBA-6B7C-4CB3-AA5D-1DBC4F41AF0A}" type="datetimeFigureOut">
               <a:rPr lang="en-US" smtClean="0"/>
-              <a:t>5/20/2026</a:t>
+              <a:t>5/30/2026</a:t>
             </a:fld>
             <a:endParaRPr lang="en-US"/>
           </a:p>
@@ -1120,7 +1120,7 @@
           <a:p>
             <a:fld id="{57E72EBA-6B7C-4CB3-AA5D-1DBC4F41AF0A}" type="datetimeFigureOut">
               <a:rPr lang="en-US" smtClean="0"/>
-              <a:t>5/20/2026</a:t>
+              <a:t>5/30/2026</a:t>
             </a:fld>
             <a:endParaRPr lang="en-US"/>
           </a:p>
@@ -1318,7 +1318,7 @@
           <a:p>
             <a:fld id="{57E72EBA-6B7C-4CB3-AA5D-1DBC4F41AF0A}" type="datetimeFigureOut">
               <a:rPr lang="en-US" smtClean="0"/>
-              <a:t>5/20/2026</a:t>
+              <a:t>5/30/2026</a:t>
             </a:fld>
             <a:endParaRPr lang="en-US"/>
           </a:p>
@@ -1593,7 +1593,7 @@
           <a:p>
             <a:fld id="{57E72EBA-6B7C-4CB3-AA5D-1DBC4F41AF0A}" type="datetimeFigureOut">
               <a:rPr lang="en-US" smtClean="0"/>
-              <a:t>5/20/2026</a:t>
+              <a:t>5/30/2026</a:t>
             </a:fld>
             <a:endParaRPr lang="en-US"/>
           </a:p>
@@ -1858,7 +1858,7 @@
           <a:p>
             <a:fld id="{57E72EBA-6B7C-4CB3-AA5D-1DBC4F41AF0A}" type="datetimeFigureOut">
               <a:rPr lang="en-US" smtClean="0"/>
-              <a:t>5/20/2026</a:t>
+              <a:t>5/30/2026</a:t>
             </a:fld>
             <a:endParaRPr lang="en-US"/>
           </a:p>
@@ -2270,7 +2270,7 @@
           <a:p>
             <a:fld id="{57E72EBA-6B7C-4CB3-AA5D-1DBC4F41AF0A}" type="datetimeFigureOut">
               <a:rPr lang="en-US" smtClean="0"/>
-              <a:t>5/20/2026</a:t>
+              <a:t>5/30/2026</a:t>
             </a:fld>
             <a:endParaRPr lang="en-US"/>
           </a:p>
@@ -2411,7 +2411,7 @@
           <a:p>
             <a:fld id="{57E72EBA-6B7C-4CB3-AA5D-1DBC4F41AF0A}" type="datetimeFigureOut">
               <a:rPr lang="en-US" smtClean="0"/>
-              <a:t>5/20/2026</a:t>
+              <a:t>5/30/2026</a:t>
             </a:fld>
             <a:endParaRPr lang="en-US"/>
           </a:p>
@@ -2524,7 +2524,7 @@
           <a:p>
             <a:fld id="{57E72EBA-6B7C-4CB3-AA5D-1DBC4F41AF0A}" type="datetimeFigureOut">
               <a:rPr lang="en-US" smtClean="0"/>
-              <a:t>5/20/2026</a:t>
+              <a:t>5/30/2026</a:t>
             </a:fld>
             <a:endParaRPr lang="en-US"/>
           </a:p>
@@ -2835,7 +2835,7 @@
           <a:p>
             <a:fld id="{57E72EBA-6B7C-4CB3-AA5D-1DBC4F41AF0A}" type="datetimeFigureOut">
               <a:rPr lang="en-US" smtClean="0"/>
-              <a:t>5/20/2026</a:t>
+              <a:t>5/30/2026</a:t>
             </a:fld>
             <a:endParaRPr lang="en-US"/>
           </a:p>
@@ -3123,7 +3123,7 @@
           <a:p>
             <a:fld id="{57E72EBA-6B7C-4CB3-AA5D-1DBC4F41AF0A}" type="datetimeFigureOut">
               <a:rPr lang="en-US" smtClean="0"/>
-              <a:t>5/20/2026</a:t>
+              <a:t>5/30/2026</a:t>
             </a:fld>
             <a:endParaRPr lang="en-US"/>
           </a:p>
@@ -3364,7 +3364,7 @@
           <a:p>
             <a:fld id="{57E72EBA-6B7C-4CB3-AA5D-1DBC4F41AF0A}" type="datetimeFigureOut">
               <a:rPr lang="en-US" smtClean="0"/>
-              <a:t>5/20/2026</a:t>
+              <a:t>5/30/2026</a:t>
             </a:fld>
             <a:endParaRPr lang="en-US"/>
           </a:p>

</xml_diff>